<commit_message>
Update PowerPoint for song #101 in FUBC - Українські
</commit_message>
<xml_diff>
--- a/fubc-ua/101-В хвилини днів безрадісних (Пісні Спасенних №96).pptx
+++ b/fubc-ua/101-В хвилини днів безрадісних (Пісні Спасенних №96).pptx
@@ -594,7 +594,7 @@
           <a:p>
             <a:r>
               <a:rPr lang="en-US" dirty="0"/>
-              <a:t>1 · 1/1</a:t>
+              <a:t>1 · 1/1 · ||:3-4:||</a:t>
             </a:r>
             <a:endParaRPr lang="en-US" dirty="0"/>
           </a:p>
@@ -682,7 +682,7 @@
           <a:p>
             <a:r>
               <a:rPr lang="en-US" dirty="0"/>
-              <a:t>2 · 1/1</a:t>
+              <a:t>2 · 1/1 · ||:3-4:||</a:t>
             </a:r>
             <a:endParaRPr lang="en-US" dirty="0"/>
           </a:p>
@@ -770,7 +770,7 @@
           <a:p>
             <a:r>
               <a:rPr lang="en-US" dirty="0"/>
-              <a:t>3 · 1/1</a:t>
+              <a:t>3 · 1/1 · ||:3-4:||</a:t>
             </a:r>
             <a:endParaRPr lang="en-US" dirty="0"/>
           </a:p>
@@ -1341,6 +1341,9 @@
           <a:lstStyle/>
           <a:p>
             <a:pPr algn="ctr" indent="0" marL="0">
+              <a:lnSpc>
+                <a:spcPts val="6200"/>
+              </a:lnSpc>
               <a:buNone/>
             </a:pPr>
             <a:r>
@@ -1358,6 +1361,9 @@
           </a:p>
           <a:p>
             <a:pPr algn="ctr" indent="0" marL="0">
+              <a:lnSpc>
+                <a:spcPts val="6200"/>
+              </a:lnSpc>
               <a:buNone/>
             </a:pPr>
             <a:r>
@@ -1375,6 +1381,9 @@
           </a:p>
           <a:p>
             <a:pPr algn="ctr" indent="0" marL="0">
+              <a:lnSpc>
+                <a:spcPts val="6200"/>
+              </a:lnSpc>
               <a:buNone/>
             </a:pPr>
             <a:r>
@@ -1386,12 +1395,15 @@
                 <a:ea typeface="Arial" pitchFamily="34" charset="-122"/>
                 <a:cs typeface="Arial" pitchFamily="34" charset="-120"/>
               </a:rPr>
-              <a:t>||: підтримкою й відрадою</a:t>
+              <a:t>підтримкою й відрадою</a:t>
             </a:r>
             <a:endParaRPr lang="en-US" sz="5200" dirty="0"/>
           </a:p>
           <a:p>
             <a:pPr algn="ctr" indent="0" marL="0">
+              <a:lnSpc>
+                <a:spcPts val="6200"/>
+              </a:lnSpc>
               <a:buNone/>
             </a:pPr>
             <a:r>
@@ -1403,9 +1415,94 @@
                 <a:ea typeface="Arial" pitchFamily="34" charset="-122"/>
                 <a:cs typeface="Arial" pitchFamily="34" charset="-120"/>
               </a:rPr>
-              <a:t>молитва є тоді. :||</a:t>
+              <a:t>молитва є тоді.</a:t>
             </a:r>
             <a:endParaRPr lang="en-US" sz="5200" dirty="0"/>
+          </a:p>
+        </p:txBody>
+      </p:sp>
+      <p:sp>
+        <p:nvSpPr>
+          <p:cNvPr id="3" name="Shape 1"/>
+          <p:cNvSpPr/>
+          <p:nvPr/>
+        </p:nvSpPr>
+        <p:spPr>
+          <a:xfrm>
+            <a:off x="1937207" y="3547872"/>
+            <a:ext cx="0" cy="1386840"/>
+          </a:xfrm>
+          <a:prstGeom prst="line">
+            <a:avLst/>
+          </a:prstGeom>
+          <a:noFill/>
+          <a:ln w="25400">
+            <a:solidFill>
+              <a:srgbClr val="8A8A8A"/>
+            </a:solidFill>
+            <a:prstDash val="solid"/>
+          </a:ln>
+        </p:spPr>
+      </p:sp>
+      <p:sp>
+        <p:nvSpPr>
+          <p:cNvPr id="4" name="Shape 2"/>
+          <p:cNvSpPr/>
+          <p:nvPr/>
+        </p:nvSpPr>
+        <p:spPr>
+          <a:xfrm>
+            <a:off x="10260889" y="3547872"/>
+            <a:ext cx="0" cy="1386840"/>
+          </a:xfrm>
+          <a:prstGeom prst="line">
+            <a:avLst/>
+          </a:prstGeom>
+          <a:noFill/>
+          <a:ln w="25400">
+            <a:solidFill>
+              <a:srgbClr val="8A8A8A"/>
+            </a:solidFill>
+            <a:prstDash val="solid"/>
+          </a:ln>
+        </p:spPr>
+      </p:sp>
+      <p:sp>
+        <p:nvSpPr>
+          <p:cNvPr id="5" name="Text 3"/>
+          <p:cNvSpPr txBox="1"/>
+          <p:nvPr/>
+        </p:nvSpPr>
+        <p:spPr>
+          <a:xfrm>
+            <a:off x="10359949" y="3921252"/>
+            <a:ext cx="1097280" cy="640080"/>
+          </a:xfrm>
+          <a:prstGeom prst="rect">
+            <a:avLst/>
+          </a:prstGeom>
+          <a:noFill/>
+          <a:ln/>
+        </p:spPr>
+        <p:txBody>
+          <a:bodyPr wrap="square" lIns="0" tIns="0" rIns="0" bIns="0" rtlCol="0" anchor="ctr"/>
+          <a:lstStyle/>
+          <a:p>
+            <a:pPr algn="l" indent="0" marL="0">
+              <a:buNone/>
+            </a:pPr>
+            <a:r>
+              <a:rPr lang="en-US" sz="3600" b="1" dirty="0">
+                <a:solidFill>
+                  <a:srgbClr val="BBBBBB"/>
+                </a:solidFill>
+                <a:latin typeface="Arial" pitchFamily="34" charset="0"/>
+                <a:ea typeface="Arial" pitchFamily="34" charset="-122"/>
+                <a:cs typeface="Arial" pitchFamily="34" charset="-120"/>
+              </a:rPr>
+              <a:t>×2</a:t>
+            </a:r>
+            <a:endParaRPr lang="en-US" sz="3600" dirty="0"/>
           </a:p>
         </p:txBody>
       </p:sp>
@@ -1463,6 +1560,9 @@
           <a:lstStyle/>
           <a:p>
             <a:pPr algn="ctr" indent="0" marL="0">
+              <a:lnSpc>
+                <a:spcPts val="6200"/>
+              </a:lnSpc>
               <a:buNone/>
             </a:pPr>
             <a:r>
@@ -1480,6 +1580,9 @@
           </a:p>
           <a:p>
             <a:pPr algn="ctr" indent="0" marL="0">
+              <a:lnSpc>
+                <a:spcPts val="6200"/>
+              </a:lnSpc>
               <a:buNone/>
             </a:pPr>
             <a:r>
@@ -1497,6 +1600,9 @@
           </a:p>
           <a:p>
             <a:pPr algn="ctr" indent="0" marL="0">
+              <a:lnSpc>
+                <a:spcPts val="6200"/>
+              </a:lnSpc>
               <a:buNone/>
             </a:pPr>
             <a:r>
@@ -1508,12 +1614,15 @@
                 <a:ea typeface="Arial" pitchFamily="34" charset="-122"/>
                 <a:cs typeface="Arial" pitchFamily="34" charset="-120"/>
               </a:rPr>
-              <a:t>||: таємна, життєдайная,</a:t>
+              <a:t>таємна, життєдайная,</a:t>
             </a:r>
             <a:endParaRPr lang="en-US" sz="5200" dirty="0"/>
           </a:p>
           <a:p>
             <a:pPr algn="ctr" indent="0" marL="0">
+              <a:lnSpc>
+                <a:spcPts val="6200"/>
+              </a:lnSpc>
               <a:buNone/>
             </a:pPr>
             <a:r>
@@ -1525,9 +1634,94 @@
                 <a:ea typeface="Arial" pitchFamily="34" charset="-122"/>
                 <a:cs typeface="Arial" pitchFamily="34" charset="-120"/>
               </a:rPr>
-              <a:t>свята краса у них. :||</a:t>
+              <a:t>свята краса у них.</a:t>
             </a:r>
             <a:endParaRPr lang="en-US" sz="5200" dirty="0"/>
+          </a:p>
+        </p:txBody>
+      </p:sp>
+      <p:sp>
+        <p:nvSpPr>
+          <p:cNvPr id="3" name="Shape 1"/>
+          <p:cNvSpPr/>
+          <p:nvPr/>
+        </p:nvSpPr>
+        <p:spPr>
+          <a:xfrm>
+            <a:off x="2322551" y="3547872"/>
+            <a:ext cx="0" cy="1386840"/>
+          </a:xfrm>
+          <a:prstGeom prst="line">
+            <a:avLst/>
+          </a:prstGeom>
+          <a:noFill/>
+          <a:ln w="25400">
+            <a:solidFill>
+              <a:srgbClr val="8A8A8A"/>
+            </a:solidFill>
+            <a:prstDash val="solid"/>
+          </a:ln>
+        </p:spPr>
+      </p:sp>
+      <p:sp>
+        <p:nvSpPr>
+          <p:cNvPr id="4" name="Shape 2"/>
+          <p:cNvSpPr/>
+          <p:nvPr/>
+        </p:nvSpPr>
+        <p:spPr>
+          <a:xfrm>
+            <a:off x="9875545" y="3547872"/>
+            <a:ext cx="0" cy="1386840"/>
+          </a:xfrm>
+          <a:prstGeom prst="line">
+            <a:avLst/>
+          </a:prstGeom>
+          <a:noFill/>
+          <a:ln w="25400">
+            <a:solidFill>
+              <a:srgbClr val="8A8A8A"/>
+            </a:solidFill>
+            <a:prstDash val="solid"/>
+          </a:ln>
+        </p:spPr>
+      </p:sp>
+      <p:sp>
+        <p:nvSpPr>
+          <p:cNvPr id="5" name="Text 3"/>
+          <p:cNvSpPr txBox="1"/>
+          <p:nvPr/>
+        </p:nvSpPr>
+        <p:spPr>
+          <a:xfrm>
+            <a:off x="9974605" y="3921252"/>
+            <a:ext cx="1097280" cy="640080"/>
+          </a:xfrm>
+          <a:prstGeom prst="rect">
+            <a:avLst/>
+          </a:prstGeom>
+          <a:noFill/>
+          <a:ln/>
+        </p:spPr>
+        <p:txBody>
+          <a:bodyPr wrap="square" lIns="0" tIns="0" rIns="0" bIns="0" rtlCol="0" anchor="ctr"/>
+          <a:lstStyle/>
+          <a:p>
+            <a:pPr algn="l" indent="0" marL="0">
+              <a:buNone/>
+            </a:pPr>
+            <a:r>
+              <a:rPr lang="en-US" sz="3600" b="1" dirty="0">
+                <a:solidFill>
+                  <a:srgbClr val="BBBBBB"/>
+                </a:solidFill>
+                <a:latin typeface="Arial" pitchFamily="34" charset="0"/>
+                <a:ea typeface="Arial" pitchFamily="34" charset="-122"/>
+                <a:cs typeface="Arial" pitchFamily="34" charset="-120"/>
+              </a:rPr>
+              <a:t>×2</a:t>
+            </a:r>
+            <a:endParaRPr lang="en-US" sz="3600" dirty="0"/>
           </a:p>
         </p:txBody>
       </p:sp>
@@ -1585,6 +1779,9 @@
           <a:lstStyle/>
           <a:p>
             <a:pPr algn="ctr" indent="0" marL="0">
+              <a:lnSpc>
+                <a:spcPts val="6200"/>
+              </a:lnSpc>
               <a:buNone/>
             </a:pPr>
             <a:r>
@@ -1602,6 +1799,9 @@
           </a:p>
           <a:p>
             <a:pPr algn="ctr" indent="0" marL="0">
+              <a:lnSpc>
+                <a:spcPts val="6200"/>
+              </a:lnSpc>
               <a:buNone/>
             </a:pPr>
             <a:r>
@@ -1619,6 +1819,9 @@
           </a:p>
           <a:p>
             <a:pPr algn="ctr" indent="0" marL="0">
+              <a:lnSpc>
+                <a:spcPts val="6200"/>
+              </a:lnSpc>
               <a:buNone/>
             </a:pPr>
             <a:r>
@@ -1630,12 +1833,15 @@
                 <a:ea typeface="Arial" pitchFamily="34" charset="-122"/>
                 <a:cs typeface="Arial" pitchFamily="34" charset="-120"/>
               </a:rPr>
-              <a:t>||: і плачеться, і віриться,</a:t>
+              <a:t>і плачеться, і віриться,</a:t>
             </a:r>
             <a:endParaRPr lang="en-US" sz="5200" dirty="0"/>
           </a:p>
           <a:p>
             <a:pPr algn="ctr" indent="0" marL="0">
+              <a:lnSpc>
+                <a:spcPts val="6200"/>
+              </a:lnSpc>
               <a:buNone/>
             </a:pPr>
             <a:r>
@@ -1647,7 +1853,7 @@
                 <a:ea typeface="Arial" pitchFamily="34" charset="-122"/>
                 <a:cs typeface="Arial" pitchFamily="34" charset="-120"/>
               </a:rPr>
-              <a:t>і легко так мені. :||</a:t>
+              <a:t>і легко так мені.</a:t>
             </a:r>
             <a:endParaRPr lang="en-US" sz="5200" dirty="0"/>
           </a:p>
@@ -1655,7 +1861,92 @@
       </p:sp>
       <p:sp>
         <p:nvSpPr>
-          <p:cNvPr id="3" name="Text 1"/>
+          <p:cNvPr id="3" name="Shape 1"/>
+          <p:cNvSpPr/>
+          <p:nvPr/>
+        </p:nvSpPr>
+        <p:spPr>
+          <a:xfrm>
+            <a:off x="2075561" y="3547872"/>
+            <a:ext cx="0" cy="1386840"/>
+          </a:xfrm>
+          <a:prstGeom prst="line">
+            <a:avLst/>
+          </a:prstGeom>
+          <a:noFill/>
+          <a:ln w="25400">
+            <a:solidFill>
+              <a:srgbClr val="8A8A8A"/>
+            </a:solidFill>
+            <a:prstDash val="solid"/>
+          </a:ln>
+        </p:spPr>
+      </p:sp>
+      <p:sp>
+        <p:nvSpPr>
+          <p:cNvPr id="4" name="Shape 2"/>
+          <p:cNvSpPr/>
+          <p:nvPr/>
+        </p:nvSpPr>
+        <p:spPr>
+          <a:xfrm>
+            <a:off x="10122535" y="3547872"/>
+            <a:ext cx="0" cy="1386840"/>
+          </a:xfrm>
+          <a:prstGeom prst="line">
+            <a:avLst/>
+          </a:prstGeom>
+          <a:noFill/>
+          <a:ln w="25400">
+            <a:solidFill>
+              <a:srgbClr val="8A8A8A"/>
+            </a:solidFill>
+            <a:prstDash val="solid"/>
+          </a:ln>
+        </p:spPr>
+      </p:sp>
+      <p:sp>
+        <p:nvSpPr>
+          <p:cNvPr id="5" name="Text 3"/>
+          <p:cNvSpPr txBox="1"/>
+          <p:nvPr/>
+        </p:nvSpPr>
+        <p:spPr>
+          <a:xfrm>
+            <a:off x="10221595" y="3921252"/>
+            <a:ext cx="1097280" cy="640080"/>
+          </a:xfrm>
+          <a:prstGeom prst="rect">
+            <a:avLst/>
+          </a:prstGeom>
+          <a:noFill/>
+          <a:ln/>
+        </p:spPr>
+        <p:txBody>
+          <a:bodyPr wrap="square" lIns="0" tIns="0" rIns="0" bIns="0" rtlCol="0" anchor="ctr"/>
+          <a:lstStyle/>
+          <a:p>
+            <a:pPr algn="l" indent="0" marL="0">
+              <a:buNone/>
+            </a:pPr>
+            <a:r>
+              <a:rPr lang="en-US" sz="3600" b="1" dirty="0">
+                <a:solidFill>
+                  <a:srgbClr val="BBBBBB"/>
+                </a:solidFill>
+                <a:latin typeface="Arial" pitchFamily="34" charset="0"/>
+                <a:ea typeface="Arial" pitchFamily="34" charset="-122"/>
+                <a:cs typeface="Arial" pitchFamily="34" charset="-120"/>
+              </a:rPr>
+              <a:t>×2</a:t>
+            </a:r>
+            <a:endParaRPr lang="en-US" sz="3600" dirty="0"/>
+          </a:p>
+        </p:txBody>
+      </p:sp>
+      <p:sp>
+        <p:nvSpPr>
+          <p:cNvPr id="6" name="Text 4"/>
           <p:cNvSpPr txBox="1"/>
           <p:nvPr/>
         </p:nvSpPr>

</xml_diff>